<commit_message>
Switch pptx font to ＭＳ Ｐゴシック (latin/ea/cs)
ユーザー指定により游ゴシックから ＭＳ Ｐゴシック に統一。
latin だけでなく ea/cs typeface も設定して日本語を確実に当てる。

Co-Authored-By: Claude Opus 4.8 <noreply@anthropic.com>
</commit_message>
<xml_diff>
--- a/docs/Pitch_Log_Report_v2.pptx
+++ b/docs/Pitch_Log_Report_v2.pptx
@@ -3167,7 +3167,9 @@
                 <a:solidFill>
                   <a:srgbClr val="1E5C3F"/>
                 </a:solidFill>
-                <a:latin typeface="游ゴシック"/>
+                <a:latin typeface="ＭＳ Ｐゴシック"/>
+                <a:ea typeface="ＭＳ Ｐゴシック"/>
+                <a:cs typeface="ＭＳ Ｐゴシック"/>
               </a:rPr>
               <a:t>提案 ｜ 選手の貢献を“因果”で評価する</a:t>
             </a:r>
@@ -3206,7 +3208,9 @@
                 <a:solidFill>
                   <a:srgbClr val="1F2A26"/>
                 </a:solidFill>
-                <a:latin typeface="游ゴシック"/>
+                <a:latin typeface="ＭＳ Ｐゴシック"/>
+                <a:ea typeface="ＭＳ Ｐゴシック"/>
+                <a:cs typeface="ＭＳ Ｐゴシック"/>
               </a:rPr>
               <a:t>選手の「なぜ必要か」を、因果で言える</a:t>
             </a:r>
@@ -3245,7 +3249,9 @@
                 <a:solidFill>
                   <a:srgbClr val="5A6663"/>
                 </a:solidFill>
-                <a:latin typeface="游ゴシック"/>
+                <a:latin typeface="ＭＳ Ｐゴシック"/>
+                <a:ea typeface="ＭＳ Ｐゴシック"/>
+                <a:cs typeface="ＭＳ Ｐゴシック"/>
               </a:rPr>
               <a:t>“効いた量（相関）”ではなく、“なぜ効くか（因果）”を1枚のレポートで示す。</a:t>
             </a:r>
@@ -3284,7 +3290,9 @@
                 <a:solidFill>
                   <a:srgbClr val="9AA5A1"/>
                 </a:solidFill>
-                <a:latin typeface="游ゴシック"/>
+                <a:latin typeface="ＭＳ Ｐゴシック"/>
+                <a:ea typeface="ＭＳ Ｐゴシック"/>
+                <a:cs typeface="ＭＳ Ｐゴシック"/>
               </a:rPr>
               <a:t>PitchLog  |  MAZDA 新規事業開発</a:t>
             </a:r>
@@ -3415,7 +3423,9 @@
                 <a:solidFill>
                   <a:srgbClr val="1E5C3F"/>
                 </a:solidFill>
-                <a:latin typeface="游ゴシック"/>
+                <a:latin typeface="ＭＳ Ｐゴシック"/>
+                <a:ea typeface="ＭＳ Ｐゴシック"/>
+                <a:cs typeface="ＭＳ Ｐゴシック"/>
               </a:rPr>
               <a:t>① なぜ必要かを言える</a:t>
             </a:r>
@@ -3454,7 +3464,9 @@
                 <a:solidFill>
                   <a:srgbClr val="C0443A"/>
                 </a:solidFill>
-                <a:latin typeface="游ゴシック"/>
+                <a:latin typeface="ＭＳ Ｐゴシック"/>
+                <a:ea typeface="ＭＳ Ｐゴシック"/>
+                <a:cs typeface="ＭＳ Ｐゴシック"/>
               </a:rPr>
               <a:t>−34%</a:t>
             </a:r>
@@ -3493,7 +3505,9 @@
                 <a:solidFill>
                   <a:srgbClr val="5A6663"/>
                 </a:solidFill>
-                <a:latin typeface="游ゴシック"/>
+                <a:latin typeface="ＭＳ Ｐゴシック"/>
+                <a:ea typeface="ＭＳ Ｐゴシック"/>
+                <a:cs typeface="ＭＳ Ｐゴシック"/>
               </a:rPr>
               <a:t>この選手が不在なら、チーム創出脅威</a:t>
             </a:r>
@@ -3532,7 +3546,9 @@
                 <a:solidFill>
                   <a:srgbClr val="1F2A26"/>
                 </a:solidFill>
-                <a:latin typeface="游ゴシック"/>
+                <a:latin typeface="ＭＳ Ｐゴシック"/>
+                <a:ea typeface="ＭＳ Ｐゴシック"/>
+                <a:cs typeface="ＭＳ Ｐゴシック"/>
               </a:rPr>
               <a:t>・ 得点期待 0.34 → 0.06（連鎖が断絶）</a:t>
             </a:r>
@@ -3548,7 +3564,9 @@
                 <a:solidFill>
                   <a:srgbClr val="1F2A26"/>
                 </a:solidFill>
-                <a:latin typeface="游ゴシック"/>
+                <a:latin typeface="ＭＳ Ｐゴシック"/>
+                <a:ea typeface="ＭＳ Ｐゴシック"/>
+                <a:cs typeface="ＭＳ Ｐゴシック"/>
               </a:rPr>
               <a:t>・ 得点関与の 82% を経由（媒介中心性）</a:t>
             </a:r>
@@ -3679,7 +3697,9 @@
                 <a:solidFill>
                   <a:srgbClr val="1E5C3F"/>
                 </a:solidFill>
-                <a:latin typeface="游ゴシック"/>
+                <a:latin typeface="ＭＳ Ｐゴシック"/>
+                <a:ea typeface="ＭＳ Ｐゴシック"/>
+                <a:cs typeface="ＭＳ Ｐゴシック"/>
               </a:rPr>
               <a:t>② 因果関係である</a:t>
             </a:r>
@@ -3718,7 +3738,9 @@
                 <a:solidFill>
                   <a:srgbClr val="1F2A26"/>
                 </a:solidFill>
-                <a:latin typeface="游ゴシック"/>
+                <a:latin typeface="ＭＳ Ｐゴシック"/>
+                <a:ea typeface="ＭＳ Ｐゴシック"/>
+                <a:cs typeface="ＭＳ Ｐゴシック"/>
               </a:rPr>
               <a:t>動き(t) → +0.5秒で味方の脅威↑</a:t>
             </a:r>
@@ -3757,7 +3779,9 @@
                 <a:solidFill>
                   <a:srgbClr val="5A6663"/>
                 </a:solidFill>
-                <a:latin typeface="游ゴシック"/>
+                <a:latin typeface="ＭＳ Ｐゴシック"/>
+                <a:ea typeface="ＭＳ Ｐゴシック"/>
+                <a:cs typeface="ＭＳ Ｐゴシック"/>
               </a:rPr>
               <a:t>時系列で“原因 → 結果”の方向を特定</a:t>
             </a:r>
@@ -3796,7 +3820,9 @@
                 <a:solidFill>
                   <a:srgbClr val="1F2A26"/>
                 </a:solidFill>
-                <a:latin typeface="游ゴシック"/>
+                <a:latin typeface="ＭＳ Ｐゴシック"/>
+                <a:ea typeface="ＭＳ Ｐゴシック"/>
+                <a:cs typeface="ＭＳ Ｐゴシック"/>
               </a:rPr>
               <a:t>・ 同時に起きた“相関”ではない</a:t>
             </a:r>
@@ -3812,7 +3838,9 @@
                 <a:solidFill>
                   <a:srgbClr val="1F2A26"/>
                 </a:solidFill>
-                <a:latin typeface="游ゴシック"/>
+                <a:latin typeface="ＭＳ Ｐゴシック"/>
+                <a:ea typeface="ＭＳ Ｐゴシック"/>
+                <a:cs typeface="ＭＳ Ｐゴシック"/>
               </a:rPr>
               <a:t>・ 不在を仮想して効果を検証（反実仮想）</a:t>
             </a:r>
@@ -3851,7 +3879,9 @@
                 <a:solidFill>
                   <a:srgbClr val="5A6663"/>
                 </a:solidFill>
-                <a:latin typeface="游ゴシック"/>
+                <a:latin typeface="ＭＳ Ｐゴシック"/>
+                <a:ea typeface="ＭＳ Ｐゴシック"/>
+                <a:cs typeface="ＭＳ Ｐゴシック"/>
               </a:rPr>
               <a:t>既存ツール＝相関の絵（合計 xT・VAEP・レーダー）。 PitchLog＝因果の根拠を、納品レポート1枚に。</a:t>
             </a:r>
@@ -3952,7 +3982,9 @@
                 <a:solidFill>
                   <a:srgbClr val="1E5C3F"/>
                 </a:solidFill>
-                <a:latin typeface="游ゴシック"/>
+                <a:latin typeface="ＭＳ Ｐゴシック"/>
+                <a:ea typeface="ＭＳ Ｐゴシック"/>
+                <a:cs typeface="ＭＳ Ｐゴシック"/>
               </a:rPr>
               <a:t>アウトプット ｜ 選手評価レポート（攻撃編・サンプル）</a:t>
             </a:r>
@@ -3991,7 +4023,9 @@
                 <a:solidFill>
                   <a:srgbClr val="1F2A26"/>
                 </a:solidFill>
-                <a:latin typeface="游ゴシック"/>
+                <a:latin typeface="ＭＳ Ｐゴシック"/>
+                <a:ea typeface="ＭＳ Ｐゴシック"/>
+                <a:cs typeface="ＭＳ Ｐゴシック"/>
               </a:rPr>
               <a:t>不在だと、得点への連鎖が途切れる</a:t>
             </a:r>
@@ -4030,7 +4064,9 @@
                 <a:solidFill>
                   <a:srgbClr val="5A6663"/>
                 </a:solidFill>
-                <a:latin typeface="游ゴシック"/>
+                <a:latin typeface="ＭＳ Ｐゴシック"/>
+                <a:ea typeface="ＭＳ Ｐゴシック"/>
+                <a:cs typeface="ＭＳ Ｐゴシック"/>
               </a:rPr>
               <a:t>M. Tanaka ・ セントラルMF ・ 総合 87 ・ 推定 €12.5M ・ 判定：獲得推奨</a:t>
             </a:r>
@@ -4069,7 +4105,9 @@
                 <a:solidFill>
                   <a:srgbClr val="9AA5A1"/>
                 </a:solidFill>
-                <a:latin typeface="游ゴシック"/>
+                <a:latin typeface="ＭＳ Ｐゴシック"/>
+                <a:ea typeface="ＭＳ Ｐゴシック"/>
+                <a:cs typeface="ＭＳ Ｐゴシック"/>
               </a:rPr>
               <a:t>PitchLog  |  MAZDA 新規事業開発</a:t>
             </a:r>
@@ -4108,7 +4146,9 @@
                 <a:solidFill>
                   <a:srgbClr val="1E5C3F"/>
                 </a:solidFill>
-                <a:latin typeface="游ゴシック"/>
+                <a:latin typeface="ＭＳ Ｐゴシック"/>
+                <a:ea typeface="ＭＳ Ｐゴシック"/>
+                <a:cs typeface="ＭＳ Ｐゴシック"/>
               </a:rPr>
               <a:t>在籍：連鎖が通り、得点へ</a:t>
             </a:r>
@@ -4337,7 +4377,9 @@
                 <a:solidFill>
                   <a:srgbClr val="1F2A26"/>
                 </a:solidFill>
-                <a:latin typeface="游ゴシック"/>
+                <a:latin typeface="ＭＳ Ｐゴシック"/>
+                <a:ea typeface="ＭＳ Ｐゴシック"/>
+                <a:cs typeface="ＭＳ Ｐゴシック"/>
               </a:rPr>
               <a:t>CM</a:t>
             </a:r>
@@ -4376,7 +4418,9 @@
                 <a:solidFill>
                   <a:srgbClr val="5A6663"/>
                 </a:solidFill>
-                <a:latin typeface="游ゴシック"/>
+                <a:latin typeface="ＭＳ Ｐゴシック"/>
+                <a:ea typeface="ＭＳ Ｐゴシック"/>
+                <a:cs typeface="ＭＳ Ｐゴシック"/>
               </a:rPr>
               <a:t>奪回</a:t>
             </a:r>
@@ -4461,7 +4505,9 @@
                 <a:solidFill>
                   <a:srgbClr val="1F2A26"/>
                 </a:solidFill>
-                <a:latin typeface="游ゴシック"/>
+                <a:latin typeface="ＭＳ Ｐゴシック"/>
+                <a:ea typeface="ＭＳ Ｐゴシック"/>
+                <a:cs typeface="ＭＳ Ｐゴシック"/>
               </a:rPr>
               <a:t>FB</a:t>
             </a:r>
@@ -4500,7 +4546,9 @@
                 <a:solidFill>
                   <a:srgbClr val="5A6663"/>
                 </a:solidFill>
-                <a:latin typeface="游ゴシック"/>
+                <a:latin typeface="ＭＳ Ｐゴシック"/>
+                <a:ea typeface="ＭＳ Ｐゴシック"/>
+                <a:cs typeface="ＭＳ Ｐゴシック"/>
               </a:rPr>
               <a:t>配球</a:t>
             </a:r>
@@ -4583,7 +4631,9 @@
                 <a:solidFill>
                   <a:srgbClr val="FFFFFF"/>
                 </a:solidFill>
-                <a:latin typeface="游ゴシック"/>
+                <a:latin typeface="ＭＳ Ｐゴシック"/>
+                <a:ea typeface="ＭＳ Ｐゴシック"/>
+                <a:cs typeface="ＭＳ Ｐゴシック"/>
               </a:rPr>
               <a:t>田中</a:t>
             </a:r>
@@ -4622,7 +4672,9 @@
                 <a:solidFill>
                   <a:srgbClr val="1E5C3F"/>
                 </a:solidFill>
-                <a:latin typeface="游ゴシック"/>
+                <a:latin typeface="ＭＳ Ｐゴシック"/>
+                <a:ea typeface="ＭＳ Ｐゴシック"/>
+                <a:cs typeface="ＭＳ Ｐゴシック"/>
               </a:rPr>
               <a:t>オフボール牽引</a:t>
             </a:r>
@@ -4707,7 +4759,9 @@
                 <a:solidFill>
                   <a:srgbClr val="1F2A26"/>
                 </a:solidFill>
-                <a:latin typeface="游ゴシック"/>
+                <a:latin typeface="ＭＳ Ｐゴシック"/>
+                <a:ea typeface="ＭＳ Ｐゴシック"/>
+                <a:cs typeface="ＭＳ Ｐゴシック"/>
               </a:rPr>
               <a:t>A</a:t>
             </a:r>
@@ -4746,7 +4800,9 @@
                 <a:solidFill>
                   <a:srgbClr val="5A6663"/>
                 </a:solidFill>
-                <a:latin typeface="游ゴシック"/>
+                <a:latin typeface="ＭＳ Ｐゴシック"/>
+                <a:ea typeface="ＭＳ Ｐゴシック"/>
+                <a:cs typeface="ＭＳ Ｐゴシック"/>
               </a:rPr>
               <a:t>スルーパス</a:t>
             </a:r>
@@ -4831,7 +4887,9 @@
                 <a:solidFill>
                   <a:srgbClr val="1E5C3F"/>
                 </a:solidFill>
-                <a:latin typeface="游ゴシック"/>
+                <a:latin typeface="ＭＳ Ｐゴシック"/>
+                <a:ea typeface="ＭＳ Ｐゴシック"/>
+                <a:cs typeface="ＭＳ Ｐゴシック"/>
               </a:rPr>
               <a:t>FW</a:t>
             </a:r>
@@ -4870,7 +4928,9 @@
                 <a:solidFill>
                   <a:srgbClr val="1E5C3F"/>
                 </a:solidFill>
-                <a:latin typeface="游ゴシック"/>
+                <a:latin typeface="ＭＳ Ｐゴシック"/>
+                <a:ea typeface="ＭＳ Ｐゴシック"/>
+                <a:cs typeface="ＭＳ Ｐゴシック"/>
               </a:rPr>
               <a:t>シュート</a:t>
             </a:r>
@@ -4909,7 +4969,9 @@
                 <a:solidFill>
                   <a:srgbClr val="1F2A26"/>
                 </a:solidFill>
-                <a:latin typeface="游ゴシック"/>
+                <a:latin typeface="ＭＳ Ｐゴシック"/>
+                <a:ea typeface="ＭＳ Ｐゴシック"/>
+                <a:cs typeface="ＭＳ Ｐゴシック"/>
               </a:rPr>
               <a:t>→ 得点期待 0.34（得点）</a:t>
             </a:r>
@@ -4984,7 +5046,9 @@
                 <a:solidFill>
                   <a:srgbClr val="C0443A"/>
                 </a:solidFill>
-                <a:latin typeface="游ゴシック"/>
+                <a:latin typeface="ＭＳ Ｐゴシック"/>
+                <a:ea typeface="ＭＳ Ｐゴシック"/>
+                <a:cs typeface="ＭＳ Ｐゴシック"/>
               </a:rPr>
               <a:t>不在（反実仮想）：経由点が消え、連鎖が断絶</a:t>
             </a:r>
@@ -5215,7 +5279,9 @@
                 <a:solidFill>
                   <a:srgbClr val="1F2A26"/>
                 </a:solidFill>
-                <a:latin typeface="游ゴシック"/>
+                <a:latin typeface="ＭＳ Ｐゴシック"/>
+                <a:ea typeface="ＭＳ Ｐゴシック"/>
+                <a:cs typeface="ＭＳ Ｐゴシック"/>
               </a:rPr>
               <a:t>CM</a:t>
             </a:r>
@@ -5254,7 +5320,9 @@
                 <a:solidFill>
                   <a:srgbClr val="5A6663"/>
                 </a:solidFill>
-                <a:latin typeface="游ゴシック"/>
+                <a:latin typeface="ＭＳ Ｐゴシック"/>
+                <a:ea typeface="ＭＳ Ｐゴシック"/>
+                <a:cs typeface="ＭＳ Ｐゴシック"/>
               </a:rPr>
               <a:t>奪回</a:t>
             </a:r>
@@ -5339,7 +5407,9 @@
                 <a:solidFill>
                   <a:srgbClr val="1F2A26"/>
                 </a:solidFill>
-                <a:latin typeface="游ゴシック"/>
+                <a:latin typeface="ＭＳ Ｐゴシック"/>
+                <a:ea typeface="ＭＳ Ｐゴシック"/>
+                <a:cs typeface="ＭＳ Ｐゴシック"/>
               </a:rPr>
               <a:t>FB</a:t>
             </a:r>
@@ -5378,7 +5448,9 @@
                 <a:solidFill>
                   <a:srgbClr val="5A6663"/>
                 </a:solidFill>
-                <a:latin typeface="游ゴシック"/>
+                <a:latin typeface="ＭＳ Ｐゴシック"/>
+                <a:ea typeface="ＭＳ Ｐゴシック"/>
+                <a:cs typeface="ＭＳ Ｐゴシック"/>
               </a:rPr>
               <a:t>配球</a:t>
             </a:r>
@@ -5463,7 +5535,9 @@
                 <a:solidFill>
                   <a:srgbClr val="9AA5A1"/>
                 </a:solidFill>
-                <a:latin typeface="游ゴシック"/>
+                <a:latin typeface="ＭＳ Ｐゴシック"/>
+                <a:ea typeface="ＭＳ Ｐゴシック"/>
+                <a:cs typeface="ＭＳ Ｐゴシック"/>
               </a:rPr>
               <a:t>—</a:t>
             </a:r>
@@ -5502,7 +5576,9 @@
                 <a:solidFill>
                   <a:srgbClr val="9AA5A1"/>
                 </a:solidFill>
-                <a:latin typeface="游ゴシック"/>
+                <a:latin typeface="ＭＳ Ｐゴシック"/>
+                <a:ea typeface="ＭＳ Ｐゴシック"/>
+                <a:cs typeface="ＭＳ Ｐゴシック"/>
               </a:rPr>
               <a:t>不在</a:t>
             </a:r>
@@ -5587,7 +5663,9 @@
                 <a:solidFill>
                   <a:srgbClr val="C0443A"/>
                 </a:solidFill>
-                <a:latin typeface="游ゴシック"/>
+                <a:latin typeface="ＭＳ Ｐゴシック"/>
+                <a:ea typeface="ＭＳ Ｐゴシック"/>
+                <a:cs typeface="ＭＳ Ｐゴシック"/>
               </a:rPr>
               <a:t>A</a:t>
             </a:r>
@@ -5626,7 +5704,9 @@
                 <a:solidFill>
                   <a:srgbClr val="C0443A"/>
                 </a:solidFill>
-                <a:latin typeface="游ゴシック"/>
+                <a:latin typeface="ＭＳ Ｐゴシック"/>
+                <a:ea typeface="ＭＳ Ｐゴシック"/>
+                <a:cs typeface="ＭＳ Ｐゴシック"/>
               </a:rPr>
               <a:t>パス先消失</a:t>
             </a:r>
@@ -5711,7 +5791,9 @@
                 <a:solidFill>
                   <a:srgbClr val="C0443A"/>
                 </a:solidFill>
-                <a:latin typeface="游ゴシック"/>
+                <a:latin typeface="ＭＳ Ｐゴシック"/>
+                <a:ea typeface="ＭＳ Ｐゴシック"/>
+                <a:cs typeface="ＭＳ Ｐゴシック"/>
               </a:rPr>
               <a:t>FW</a:t>
             </a:r>
@@ -5750,7 +5832,9 @@
                 <a:solidFill>
                   <a:srgbClr val="C0443A"/>
                 </a:solidFill>
-                <a:latin typeface="游ゴシック"/>
+                <a:latin typeface="ＭＳ Ｐゴシック"/>
+                <a:ea typeface="ＭＳ Ｐゴシック"/>
+                <a:cs typeface="ＭＳ Ｐゴシック"/>
               </a:rPr>
               <a:t>機会消失</a:t>
             </a:r>
@@ -5789,7 +5873,9 @@
                 <a:solidFill>
                   <a:srgbClr val="C0443A"/>
                 </a:solidFill>
-                <a:latin typeface="游ゴシック"/>
+                <a:latin typeface="ＭＳ Ｐゴシック"/>
+                <a:ea typeface="ＭＳ Ｐゴシック"/>
+                <a:cs typeface="ＭＳ Ｐゴシック"/>
               </a:rPr>
               <a:t>→ 得点期待 0.06（−82%・断絶）</a:t>
             </a:r>
@@ -5920,7 +6006,9 @@
                 <a:solidFill>
                   <a:srgbClr val="1E5C3F"/>
                 </a:solidFill>
-                <a:latin typeface="游ゴシック"/>
+                <a:latin typeface="ＭＳ Ｐゴシック"/>
+                <a:ea typeface="ＭＳ Ｐゴシック"/>
+                <a:cs typeface="ＭＳ Ｐゴシック"/>
               </a:rPr>
               <a:t>結論：獲得推奨</a:t>
             </a:r>
@@ -5959,7 +6047,9 @@
                 <a:solidFill>
                   <a:srgbClr val="1F2A26"/>
                 </a:solidFill>
-                <a:latin typeface="游ゴシック"/>
+                <a:latin typeface="ＭＳ Ｐゴシック"/>
+                <a:ea typeface="ＭＳ Ｐゴシック"/>
+                <a:cs typeface="ＭＳ Ｐゴシック"/>
               </a:rPr>
               <a:t>不在ならチーム創出脅威 −34% ／ 得点関与の 82% を経由する代替困難な“因果ハブ”。査定 €12.5M は妥当。</a:t>
             </a:r>
@@ -6060,7 +6150,9 @@
                 <a:solidFill>
                   <a:srgbClr val="1E5C3F"/>
                 </a:solidFill>
-                <a:latin typeface="游ゴシック"/>
+                <a:latin typeface="ＭＳ Ｐゴシック"/>
+                <a:ea typeface="ＭＳ Ｐゴシック"/>
+                <a:cs typeface="ＭＳ Ｐゴシック"/>
               </a:rPr>
               <a:t>アウトプット ｜ 選手評価レポート（守備編・サンプル）</a:t>
             </a:r>
@@ -6099,7 +6191,9 @@
                 <a:solidFill>
                   <a:srgbClr val="1F2A26"/>
                 </a:solidFill>
-                <a:latin typeface="游ゴシック"/>
+                <a:latin typeface="ＭＳ Ｐゴシック"/>
+                <a:ea typeface="ＭＳ Ｐゴシック"/>
+                <a:cs typeface="ＭＳ Ｐゴシック"/>
               </a:rPr>
               <a:t>不在だと、守備ブロックが空く</a:t>
             </a:r>
@@ -6138,7 +6232,9 @@
                 <a:solidFill>
                   <a:srgbClr val="5A6663"/>
                 </a:solidFill>
-                <a:latin typeface="游ゴシック"/>
+                <a:latin typeface="ＭＳ Ｐゴシック"/>
+                <a:ea typeface="ＭＳ Ｐゴシック"/>
+                <a:cs typeface="ＭＳ Ｐゴシック"/>
               </a:rPr>
               <a:t>S. Yamamoto ・ センターバック ・ 総合 84 ・ 推定 €9.0M ・ 判定：残留必須</a:t>
             </a:r>
@@ -6177,7 +6273,9 @@
                 <a:solidFill>
                   <a:srgbClr val="9AA5A1"/>
                 </a:solidFill>
-                <a:latin typeface="游ゴシック"/>
+                <a:latin typeface="ＭＳ Ｐゴシック"/>
+                <a:ea typeface="ＭＳ Ｐゴシック"/>
+                <a:cs typeface="ＭＳ Ｐゴシック"/>
               </a:rPr>
               <a:t>PitchLog  |  MAZDA 新規事業開発</a:t>
             </a:r>
@@ -6216,7 +6314,9 @@
                 <a:solidFill>
                   <a:srgbClr val="1E5C3F"/>
                 </a:solidFill>
-                <a:latin typeface="游ゴシック"/>
+                <a:latin typeface="ＭＳ Ｐゴシック"/>
+                <a:ea typeface="ＭＳ Ｐゴシック"/>
+                <a:cs typeface="ＭＳ Ｐゴシック"/>
               </a:rPr>
               <a:t>在籍：カバーが効き、相手の前進を遮断</a:t>
             </a:r>
@@ -6445,7 +6545,9 @@
                 <a:solidFill>
                   <a:srgbClr val="1F2A26"/>
                 </a:solidFill>
-                <a:latin typeface="游ゴシック"/>
+                <a:latin typeface="ＭＳ Ｐゴシック"/>
+                <a:ea typeface="ＭＳ Ｐゴシック"/>
+                <a:cs typeface="ＭＳ Ｐゴシック"/>
               </a:rPr>
               <a:t>相手</a:t>
             </a:r>
@@ -6484,7 +6586,9 @@
                 <a:solidFill>
                   <a:srgbClr val="5A6663"/>
                 </a:solidFill>
-                <a:latin typeface="游ゴシック"/>
+                <a:latin typeface="ＭＳ Ｐゴシック"/>
+                <a:ea typeface="ＭＳ Ｐゴシック"/>
+                <a:cs typeface="ＭＳ Ｐゴシック"/>
               </a:rPr>
               <a:t>前進</a:t>
             </a:r>
@@ -6569,7 +6673,9 @@
                 <a:solidFill>
                   <a:srgbClr val="1F2A26"/>
                 </a:solidFill>
-                <a:latin typeface="游ゴシック"/>
+                <a:latin typeface="ＭＳ Ｐゴシック"/>
+                <a:ea typeface="ＭＳ Ｐゴシック"/>
+                <a:cs typeface="ＭＳ Ｐゴシック"/>
               </a:rPr>
               <a:t>相手</a:t>
             </a:r>
@@ -6608,7 +6714,9 @@
                 <a:solidFill>
                   <a:srgbClr val="5A6663"/>
                 </a:solidFill>
-                <a:latin typeface="游ゴシック"/>
+                <a:latin typeface="ＭＳ Ｐゴシック"/>
+                <a:ea typeface="ＭＳ Ｐゴシック"/>
+                <a:cs typeface="ＭＳ Ｐゴシック"/>
               </a:rPr>
               <a:t>楔パス</a:t>
             </a:r>
@@ -6691,7 +6799,9 @@
                 <a:solidFill>
                   <a:srgbClr val="FFFFFF"/>
                 </a:solidFill>
-                <a:latin typeface="游ゴシック"/>
+                <a:latin typeface="ＭＳ Ｐゴシック"/>
+                <a:ea typeface="ＭＳ Ｐゴシック"/>
+                <a:cs typeface="ＭＳ Ｐゴシック"/>
               </a:rPr>
               <a:t>山本</a:t>
             </a:r>
@@ -6730,7 +6840,9 @@
                 <a:solidFill>
                   <a:srgbClr val="1E5C3F"/>
                 </a:solidFill>
-                <a:latin typeface="游ゴシック"/>
+                <a:latin typeface="ＭＳ Ｐゴシック"/>
+                <a:ea typeface="ＭＳ Ｐゴシック"/>
+                <a:cs typeface="ＭＳ Ｐゴシック"/>
               </a:rPr>
               <a:t>遮断</a:t>
             </a:r>
@@ -6815,7 +6927,9 @@
                 <a:solidFill>
                   <a:srgbClr val="1E5C3F"/>
                 </a:solidFill>
-                <a:latin typeface="游ゴシック"/>
+                <a:latin typeface="ＭＳ Ｐゴシック"/>
+                <a:ea typeface="ＭＳ Ｐゴシック"/>
+                <a:cs typeface="ＭＳ Ｐゴシック"/>
               </a:rPr>
               <a:t>味方</a:t>
             </a:r>
@@ -6854,7 +6968,9 @@
                 <a:solidFill>
                   <a:srgbClr val="1E5C3F"/>
                 </a:solidFill>
-                <a:latin typeface="游ゴシック"/>
+                <a:latin typeface="ＭＳ Ｐゴシック"/>
+                <a:ea typeface="ＭＳ Ｐゴシック"/>
+                <a:cs typeface="ＭＳ Ｐゴシック"/>
               </a:rPr>
               <a:t>回収</a:t>
             </a:r>
@@ -6939,7 +7055,9 @@
                 <a:solidFill>
                   <a:srgbClr val="1E5C3F"/>
                 </a:solidFill>
-                <a:latin typeface="游ゴシック"/>
+                <a:latin typeface="ＭＳ Ｐゴシック"/>
+                <a:ea typeface="ＭＳ Ｐゴシック"/>
+                <a:cs typeface="ＭＳ Ｐゴシック"/>
               </a:rPr>
               <a:t>—</a:t>
             </a:r>
@@ -6978,7 +7096,9 @@
                 <a:solidFill>
                   <a:srgbClr val="1E5C3F"/>
                 </a:solidFill>
-                <a:latin typeface="游ゴシック"/>
+                <a:latin typeface="ＭＳ Ｐゴシック"/>
+                <a:ea typeface="ＭＳ Ｐゴシック"/>
+                <a:cs typeface="ＭＳ Ｐゴシック"/>
               </a:rPr>
               <a:t>脅威なし</a:t>
             </a:r>
@@ -7017,7 +7137,9 @@
                 <a:solidFill>
                   <a:srgbClr val="1F2A26"/>
                 </a:solidFill>
-                <a:latin typeface="游ゴシック"/>
+                <a:latin typeface="ＭＳ Ｐゴシック"/>
+                <a:ea typeface="ＭＳ Ｐゴシック"/>
+                <a:cs typeface="ＭＳ Ｐゴシック"/>
               </a:rPr>
               <a:t>→ 被xT 0.05（抑制）</a:t>
             </a:r>
@@ -7092,7 +7214,9 @@
                 <a:solidFill>
                   <a:srgbClr val="C0443A"/>
                 </a:solidFill>
-                <a:latin typeface="游ゴシック"/>
+                <a:latin typeface="ＭＳ Ｐゴシック"/>
+                <a:ea typeface="ＭＳ Ｐゴシック"/>
+                <a:cs typeface="ＭＳ Ｐゴシック"/>
               </a:rPr>
               <a:t>不在：ライン間が空き、中央を割られる</a:t>
             </a:r>
@@ -7323,7 +7447,9 @@
                 <a:solidFill>
                   <a:srgbClr val="1F2A26"/>
                 </a:solidFill>
-                <a:latin typeface="游ゴシック"/>
+                <a:latin typeface="ＭＳ Ｐゴシック"/>
+                <a:ea typeface="ＭＳ Ｐゴシック"/>
+                <a:cs typeface="ＭＳ Ｐゴシック"/>
               </a:rPr>
               <a:t>相手</a:t>
             </a:r>
@@ -7362,7 +7488,9 @@
                 <a:solidFill>
                   <a:srgbClr val="5A6663"/>
                 </a:solidFill>
-                <a:latin typeface="游ゴシック"/>
+                <a:latin typeface="ＭＳ Ｐゴシック"/>
+                <a:ea typeface="ＭＳ Ｐゴシック"/>
+                <a:cs typeface="ＭＳ Ｐゴシック"/>
               </a:rPr>
               <a:t>前進</a:t>
             </a:r>
@@ -7447,7 +7575,9 @@
                 <a:solidFill>
                   <a:srgbClr val="1F2A26"/>
                 </a:solidFill>
-                <a:latin typeface="游ゴシック"/>
+                <a:latin typeface="ＭＳ Ｐゴシック"/>
+                <a:ea typeface="ＭＳ Ｐゴシック"/>
+                <a:cs typeface="ＭＳ Ｐゴシック"/>
               </a:rPr>
               <a:t>相手</a:t>
             </a:r>
@@ -7486,7 +7616,9 @@
                 <a:solidFill>
                   <a:srgbClr val="5A6663"/>
                 </a:solidFill>
-                <a:latin typeface="游ゴシック"/>
+                <a:latin typeface="ＭＳ Ｐゴシック"/>
+                <a:ea typeface="ＭＳ Ｐゴシック"/>
+                <a:cs typeface="ＭＳ Ｐゴシック"/>
               </a:rPr>
               <a:t>楔パス</a:t>
             </a:r>
@@ -7571,7 +7703,9 @@
                 <a:solidFill>
                   <a:srgbClr val="9AA5A1"/>
                 </a:solidFill>
-                <a:latin typeface="游ゴシック"/>
+                <a:latin typeface="ＭＳ Ｐゴシック"/>
+                <a:ea typeface="ＭＳ Ｐゴシック"/>
+                <a:cs typeface="ＭＳ Ｐゴシック"/>
               </a:rPr>
               <a:t>—</a:t>
             </a:r>
@@ -7610,7 +7744,9 @@
                 <a:solidFill>
                   <a:srgbClr val="9AA5A1"/>
                 </a:solidFill>
-                <a:latin typeface="游ゴシック"/>
+                <a:latin typeface="ＭＳ Ｐゴシック"/>
+                <a:ea typeface="ＭＳ Ｐゴシック"/>
+                <a:cs typeface="ＭＳ Ｐゴシック"/>
               </a:rPr>
               <a:t>不在</a:t>
             </a:r>
@@ -7695,7 +7831,9 @@
                 <a:solidFill>
                   <a:srgbClr val="C0443A"/>
                 </a:solidFill>
-                <a:latin typeface="游ゴシック"/>
+                <a:latin typeface="ＭＳ Ｐゴシック"/>
+                <a:ea typeface="ＭＳ Ｐゴシック"/>
+                <a:cs typeface="ＭＳ Ｐゴシック"/>
               </a:rPr>
               <a:t>相手</a:t>
             </a:r>
@@ -7734,7 +7872,9 @@
                 <a:solidFill>
                   <a:srgbClr val="C0443A"/>
                 </a:solidFill>
-                <a:latin typeface="游ゴシック"/>
+                <a:latin typeface="ＭＳ Ｐゴシック"/>
+                <a:ea typeface="ＭＳ Ｐゴシック"/>
+                <a:cs typeface="ＭＳ Ｐゴシック"/>
               </a:rPr>
               <a:t>中央侵入</a:t>
             </a:r>
@@ -7819,7 +7959,9 @@
                 <a:solidFill>
                   <a:srgbClr val="C0443A"/>
                 </a:solidFill>
-                <a:latin typeface="游ゴシック"/>
+                <a:latin typeface="ＭＳ Ｐゴシック"/>
+                <a:ea typeface="ＭＳ Ｐゴシック"/>
+                <a:cs typeface="ＭＳ Ｐゴシック"/>
               </a:rPr>
               <a:t>相手</a:t>
             </a:r>
@@ -7858,7 +8000,9 @@
                 <a:solidFill>
                   <a:srgbClr val="C0443A"/>
                 </a:solidFill>
-                <a:latin typeface="游ゴシック"/>
+                <a:latin typeface="ＭＳ Ｐゴシック"/>
+                <a:ea typeface="ＭＳ Ｐゴシック"/>
+                <a:cs typeface="ＭＳ Ｐゴシック"/>
               </a:rPr>
               <a:t>被シュート</a:t>
             </a:r>
@@ -7897,7 +8041,9 @@
                 <a:solidFill>
                   <a:srgbClr val="C0443A"/>
                 </a:solidFill>
-                <a:latin typeface="游ゴシック"/>
+                <a:latin typeface="ＭＳ Ｐゴシック"/>
+                <a:ea typeface="ＭＳ Ｐゴシック"/>
+                <a:cs typeface="ＭＳ Ｐゴシック"/>
               </a:rPr>
               <a:t>→ 被xT 0.31（+82%・失点機会）</a:t>
             </a:r>
@@ -8028,7 +8174,9 @@
                 <a:solidFill>
                   <a:srgbClr val="1E5C3F"/>
                 </a:solidFill>
-                <a:latin typeface="游ゴシック"/>
+                <a:latin typeface="ＭＳ Ｐゴシック"/>
+                <a:ea typeface="ＭＳ Ｐゴシック"/>
+                <a:cs typeface="ＭＳ Ｐゴシック"/>
               </a:rPr>
               <a:t>結論：残留必須</a:t>
             </a:r>
@@ -8067,7 +8215,9 @@
                 <a:solidFill>
                   <a:srgbClr val="1F2A26"/>
                 </a:solidFill>
-                <a:latin typeface="游ゴシック"/>
+                <a:latin typeface="ＭＳ Ｐゴシック"/>
+                <a:ea typeface="ＭＳ Ｐゴシック"/>
+                <a:cs typeface="ＭＳ Ｐゴシック"/>
               </a:rPr>
               <a:t>不在なら被創出脅威 +38% ／ 危険地帯への侵入を 72% で阻止する守備の要。放出は守備崩壊リスク大。</a:t>
             </a:r>
@@ -8168,7 +8318,9 @@
                 <a:solidFill>
                   <a:srgbClr val="1E5C3F"/>
                 </a:solidFill>
-                <a:latin typeface="游ゴシック"/>
+                <a:latin typeface="ＭＳ Ｐゴシック"/>
+                <a:ea typeface="ＭＳ Ｐゴシック"/>
+                <a:cs typeface="ＭＳ Ｐゴシック"/>
               </a:rPr>
               <a:t>因果の担保 ｜ なぜ“相関”ではないと言えるか</a:t>
             </a:r>
@@ -8207,7 +8359,9 @@
                 <a:solidFill>
                   <a:srgbClr val="1F2A26"/>
                 </a:solidFill>
-                <a:latin typeface="游ゴシック"/>
+                <a:latin typeface="ＭＳ Ｐゴシック"/>
+                <a:ea typeface="ＭＳ Ｐゴシック"/>
+                <a:cs typeface="ＭＳ Ｐゴシック"/>
               </a:rPr>
               <a:t>なぜ“因果”と言い切れるのか</a:t>
             </a:r>
@@ -8246,7 +8400,9 @@
                 <a:solidFill>
                   <a:srgbClr val="5A6663"/>
                 </a:solidFill>
-                <a:latin typeface="游ゴシック"/>
+                <a:latin typeface="ＭＳ Ｐゴシック"/>
+                <a:ea typeface="ＭＳ Ｐゴシック"/>
+                <a:cs typeface="ＭＳ Ｐゴシック"/>
               </a:rPr>
               <a:t>相関では出せない3つの証拠で裏づける。</a:t>
             </a:r>
@@ -8285,7 +8441,9 @@
                 <a:solidFill>
                   <a:srgbClr val="9AA5A1"/>
                 </a:solidFill>
-                <a:latin typeface="游ゴシック"/>
+                <a:latin typeface="ＭＳ Ｐゴシック"/>
+                <a:ea typeface="ＭＳ Ｐゴシック"/>
+                <a:cs typeface="ＭＳ Ｐゴシック"/>
               </a:rPr>
               <a:t>PitchLog  |  MAZDA 新規事業開発</a:t>
             </a:r>
@@ -8416,7 +8574,9 @@
                 <a:solidFill>
                   <a:srgbClr val="1E5C3F"/>
                 </a:solidFill>
-                <a:latin typeface="游ゴシック"/>
+                <a:latin typeface="ＭＳ Ｐゴシック"/>
+                <a:ea typeface="ＭＳ Ｐゴシック"/>
+                <a:cs typeface="ＭＳ Ｐゴシック"/>
               </a:rPr>
               <a:t>時間ラグ</a:t>
             </a:r>
@@ -8455,7 +8615,9 @@
                 <a:solidFill>
                   <a:srgbClr val="1F2A26"/>
                 </a:solidFill>
-                <a:latin typeface="游ゴシック"/>
+                <a:latin typeface="ＭＳ Ｐゴシック"/>
+                <a:ea typeface="ＭＳ Ｐゴシック"/>
+                <a:cs typeface="ＭＳ Ｐゴシック"/>
               </a:rPr>
               <a:t>方向の特定</a:t>
             </a:r>
@@ -8802,7 +8964,9 @@
                 <a:solidFill>
                   <a:srgbClr val="5A6663"/>
                 </a:solidFill>
-                <a:latin typeface="游ゴシック"/>
+                <a:latin typeface="ＭＳ Ｐゴシック"/>
+                <a:ea typeface="ＭＳ Ｐゴシック"/>
+                <a:cs typeface="ＭＳ Ｐゴシック"/>
               </a:rPr>
               <a:t>ピークが +0.5秒側＝選手が先・</a:t>
             </a:r>
@@ -8818,7 +8982,9 @@
                 <a:solidFill>
                   <a:srgbClr val="5A6663"/>
                 </a:solidFill>
-                <a:latin typeface="游ゴシック"/>
+                <a:latin typeface="ＭＳ Ｐゴシック"/>
+                <a:ea typeface="ＭＳ Ｐゴシック"/>
+                <a:cs typeface="ＭＳ Ｐゴシック"/>
               </a:rPr>
               <a:t>結果が後。同時相関ではない。</a:t>
             </a:r>
@@ -8949,7 +9115,9 @@
                 <a:solidFill>
                   <a:srgbClr val="1E5C3F"/>
                 </a:solidFill>
-                <a:latin typeface="游ゴシック"/>
+                <a:latin typeface="ＭＳ Ｐゴシック"/>
+                <a:ea typeface="ＭＳ Ｐゴシック"/>
+                <a:cs typeface="ＭＳ Ｐゴシック"/>
               </a:rPr>
               <a:t>反実仮想</a:t>
             </a:r>
@@ -8988,7 +9156,9 @@
                 <a:solidFill>
                   <a:srgbClr val="1F2A26"/>
                 </a:solidFill>
-                <a:latin typeface="游ゴシック"/>
+                <a:latin typeface="ＭＳ Ｐゴシック"/>
+                <a:ea typeface="ＭＳ Ｐゴシック"/>
+                <a:cs typeface="ＭＳ Ｐゴシック"/>
               </a:rPr>
               <a:t>介入で検証</a:t>
             </a:r>
@@ -9119,7 +9289,9 @@
                 <a:solidFill>
                   <a:srgbClr val="5A6663"/>
                 </a:solidFill>
-                <a:latin typeface="游ゴシック"/>
+                <a:latin typeface="ＭＳ Ｐゴシック"/>
+                <a:ea typeface="ＭＳ Ｐゴシック"/>
+                <a:cs typeface="ＭＳ Ｐゴシック"/>
               </a:rPr>
               <a:t>在籍</a:t>
             </a:r>
@@ -9250,7 +9422,9 @@
                 <a:solidFill>
                   <a:srgbClr val="5A6663"/>
                 </a:solidFill>
-                <a:latin typeface="游ゴシック"/>
+                <a:latin typeface="ＭＳ Ｐゴシック"/>
+                <a:ea typeface="ＭＳ Ｐゴシック"/>
+                <a:cs typeface="ＭＳ Ｐゴシック"/>
               </a:rPr>
               <a:t>不在</a:t>
             </a:r>
@@ -9289,7 +9463,9 @@
                 <a:solidFill>
                   <a:srgbClr val="5A6663"/>
                 </a:solidFill>
-                <a:latin typeface="游ゴシック"/>
+                <a:latin typeface="ＭＳ Ｐゴシック"/>
+                <a:ea typeface="ＭＳ Ｐゴシック"/>
+                <a:cs typeface="ＭＳ Ｐゴシック"/>
               </a:rPr>
               <a:t>不在を仮想して比較（−34%）。</a:t>
             </a:r>
@@ -9305,7 +9481,9 @@
                 <a:solidFill>
                   <a:srgbClr val="5A6663"/>
                 </a:solidFill>
-                <a:latin typeface="游ゴシック"/>
+                <a:latin typeface="ＭＳ Ｐゴシック"/>
+                <a:ea typeface="ＭＳ Ｐゴシック"/>
+                <a:cs typeface="ＭＳ Ｐゴシック"/>
               </a:rPr>
               <a:t>観察ではなく“介入効果”。</a:t>
             </a:r>
@@ -9436,7 +9614,9 @@
                 <a:solidFill>
                   <a:srgbClr val="1E5C3F"/>
                 </a:solidFill>
-                <a:latin typeface="游ゴシック"/>
+                <a:latin typeface="ＭＳ Ｐゴシック"/>
+                <a:ea typeface="ＭＳ Ｐゴシック"/>
+                <a:cs typeface="ＭＳ Ｐゴシック"/>
               </a:rPr>
               <a:t>連鎖の経路</a:t>
             </a:r>
@@ -9475,7 +9655,9 @@
                 <a:solidFill>
                   <a:srgbClr val="1F2A26"/>
                 </a:solidFill>
-                <a:latin typeface="游ゴシック"/>
+                <a:latin typeface="ＭＳ Ｐゴシック"/>
+                <a:ea typeface="ＭＳ Ｐゴシック"/>
+                <a:cs typeface="ＭＳ Ｐゴシック"/>
               </a:rPr>
               <a:t>経路の必須性</a:t>
             </a:r>
@@ -9725,7 +9907,9 @@
                 <a:solidFill>
                   <a:srgbClr val="9AA5A1"/>
                 </a:solidFill>
-                <a:latin typeface="游ゴシック"/>
+                <a:latin typeface="ＭＳ Ｐゴシック"/>
+                <a:ea typeface="ＭＳ Ｐゴシック"/>
+                <a:cs typeface="ＭＳ Ｐゴシック"/>
               </a:rPr>
               <a:t>不在</a:t>
             </a:r>
@@ -9764,7 +9948,9 @@
                 <a:solidFill>
                   <a:srgbClr val="5A6663"/>
                 </a:solidFill>
-                <a:latin typeface="游ゴシック"/>
+                <a:latin typeface="ＭＳ Ｐゴシック"/>
+                <a:ea typeface="ＭＳ Ｐゴシック"/>
+                <a:cs typeface="ＭＳ Ｐゴシック"/>
               </a:rPr>
               <a:t>経由点を抜くと後段が成立</a:t>
             </a:r>
@@ -9780,7 +9966,9 @@
                 <a:solidFill>
                   <a:srgbClr val="5A6663"/>
                 </a:solidFill>
-                <a:latin typeface="游ゴシック"/>
+                <a:latin typeface="ＭＳ Ｐゴシック"/>
+                <a:ea typeface="ＭＳ Ｐゴシック"/>
+                <a:cs typeface="ＭＳ Ｐゴシック"/>
               </a:rPr>
               <a:t>しない（媒介中心性 82%）。</a:t>
             </a:r>
@@ -9819,7 +10007,9 @@
                 <a:solidFill>
                   <a:srgbClr val="5A6663"/>
                 </a:solidFill>
-                <a:latin typeface="游ゴシック"/>
+                <a:latin typeface="ＭＳ Ｐゴシック"/>
+                <a:ea typeface="ＭＳ Ｐゴシック"/>
+                <a:cs typeface="ＭＳ Ｐゴシック"/>
               </a:rPr>
               <a:t>いずれも相関では出せない。だから“なぜ必要か”を、根拠を持って言える。</a:t>
             </a:r>

</xml_diff>